<commit_message>
got basic cal working at one frequency
</commit_message>
<xml_diff>
--- a/more plots.pptx
+++ b/more plots.pptx
@@ -10,6 +10,8 @@
     <p:sldId id="258" r:id="rId4"/>
     <p:sldId id="259" r:id="rId5"/>
     <p:sldId id="260" r:id="rId6"/>
+    <p:sldId id="261" r:id="rId7"/>
+    <p:sldId id="262" r:id="rId8"/>
   </p:sldIdLst>
   <p:sldSz cx="12192000" cy="6858000"/>
   <p:notesSz cx="6858000" cy="9144000"/>
@@ -108,6 +110,11 @@
       </a:defRPr>
     </a:lvl9pPr>
   </p:defaultTextStyle>
+  <p:extLst>
+    <p:ext uri="{EFAFB233-063F-42B5-8137-9DF3F51BA10A}">
+      <p15:sldGuideLst xmlns:p15="http://schemas.microsoft.com/office/powerpoint/2012/main"/>
+    </p:ext>
+  </p:extLst>
 </p:presentation>
 </file>
 
@@ -258,7 +265,7 @@
           <a:p>
             <a:fld id="{B28E41B5-CF0F-4C6C-A433-FE4891A9D215}" type="datetimeFigureOut">
               <a:rPr lang="en-US" smtClean="0"/>
-              <a:t>1/30/2026</a:t>
+              <a:t>2/2/2026</a:t>
             </a:fld>
             <a:endParaRPr lang="en-US"/>
           </a:p>
@@ -456,7 +463,7 @@
           <a:p>
             <a:fld id="{B28E41B5-CF0F-4C6C-A433-FE4891A9D215}" type="datetimeFigureOut">
               <a:rPr lang="en-US" smtClean="0"/>
-              <a:t>1/30/2026</a:t>
+              <a:t>2/2/2026</a:t>
             </a:fld>
             <a:endParaRPr lang="en-US"/>
           </a:p>
@@ -664,7 +671,7 @@
           <a:p>
             <a:fld id="{B28E41B5-CF0F-4C6C-A433-FE4891A9D215}" type="datetimeFigureOut">
               <a:rPr lang="en-US" smtClean="0"/>
-              <a:t>1/30/2026</a:t>
+              <a:t>2/2/2026</a:t>
             </a:fld>
             <a:endParaRPr lang="en-US"/>
           </a:p>
@@ -862,7 +869,7 @@
           <a:p>
             <a:fld id="{B28E41B5-CF0F-4C6C-A433-FE4891A9D215}" type="datetimeFigureOut">
               <a:rPr lang="en-US" smtClean="0"/>
-              <a:t>1/30/2026</a:t>
+              <a:t>2/2/2026</a:t>
             </a:fld>
             <a:endParaRPr lang="en-US"/>
           </a:p>
@@ -1137,7 +1144,7 @@
           <a:p>
             <a:fld id="{B28E41B5-CF0F-4C6C-A433-FE4891A9D215}" type="datetimeFigureOut">
               <a:rPr lang="en-US" smtClean="0"/>
-              <a:t>1/30/2026</a:t>
+              <a:t>2/2/2026</a:t>
             </a:fld>
             <a:endParaRPr lang="en-US"/>
           </a:p>
@@ -1402,7 +1409,7 @@
           <a:p>
             <a:fld id="{B28E41B5-CF0F-4C6C-A433-FE4891A9D215}" type="datetimeFigureOut">
               <a:rPr lang="en-US" smtClean="0"/>
-              <a:t>1/30/2026</a:t>
+              <a:t>2/2/2026</a:t>
             </a:fld>
             <a:endParaRPr lang="en-US"/>
           </a:p>
@@ -1814,7 +1821,7 @@
           <a:p>
             <a:fld id="{B28E41B5-CF0F-4C6C-A433-FE4891A9D215}" type="datetimeFigureOut">
               <a:rPr lang="en-US" smtClean="0"/>
-              <a:t>1/30/2026</a:t>
+              <a:t>2/2/2026</a:t>
             </a:fld>
             <a:endParaRPr lang="en-US"/>
           </a:p>
@@ -1955,7 +1962,7 @@
           <a:p>
             <a:fld id="{B28E41B5-CF0F-4C6C-A433-FE4891A9D215}" type="datetimeFigureOut">
               <a:rPr lang="en-US" smtClean="0"/>
-              <a:t>1/30/2026</a:t>
+              <a:t>2/2/2026</a:t>
             </a:fld>
             <a:endParaRPr lang="en-US"/>
           </a:p>
@@ -2068,7 +2075,7 @@
           <a:p>
             <a:fld id="{B28E41B5-CF0F-4C6C-A433-FE4891A9D215}" type="datetimeFigureOut">
               <a:rPr lang="en-US" smtClean="0"/>
-              <a:t>1/30/2026</a:t>
+              <a:t>2/2/2026</a:t>
             </a:fld>
             <a:endParaRPr lang="en-US"/>
           </a:p>
@@ -2379,7 +2386,7 @@
           <a:p>
             <a:fld id="{B28E41B5-CF0F-4C6C-A433-FE4891A9D215}" type="datetimeFigureOut">
               <a:rPr lang="en-US" smtClean="0"/>
-              <a:t>1/30/2026</a:t>
+              <a:t>2/2/2026</a:t>
             </a:fld>
             <a:endParaRPr lang="en-US"/>
           </a:p>
@@ -2667,7 +2674,7 @@
           <a:p>
             <a:fld id="{B28E41B5-CF0F-4C6C-A433-FE4891A9D215}" type="datetimeFigureOut">
               <a:rPr lang="en-US" smtClean="0"/>
-              <a:t>1/30/2026</a:t>
+              <a:t>2/2/2026</a:t>
             </a:fld>
             <a:endParaRPr lang="en-US"/>
           </a:p>
@@ -2908,7 +2915,7 @@
           <a:p>
             <a:fld id="{B28E41B5-CF0F-4C6C-A433-FE4891A9D215}" type="datetimeFigureOut">
               <a:rPr lang="en-US" smtClean="0"/>
-              <a:t>1/30/2026</a:t>
+              <a:t>2/2/2026</a:t>
             </a:fld>
             <a:endParaRPr lang="en-US"/>
           </a:p>
@@ -3372,6 +3379,53 @@
           </a:extLst>
         </p:spPr>
       </p:pic>
+      <p:pic>
+        <p:nvPicPr>
+          <p:cNvPr id="1025" name="Picture 1">
+            <a:extLst>
+              <a:ext uri="{FF2B5EF4-FFF2-40B4-BE49-F238E27FC236}">
+                <a16:creationId xmlns:a16="http://schemas.microsoft.com/office/drawing/2014/main" id="{24FDA7F6-73EC-C03D-171F-22A0FA9C6A77}"/>
+              </a:ext>
+            </a:extLst>
+          </p:cNvPr>
+          <p:cNvPicPr>
+            <a:picLocks noChangeAspect="1" noChangeArrowheads="1"/>
+          </p:cNvPicPr>
+          <p:nvPr/>
+        </p:nvPicPr>
+        <p:blipFill>
+          <a:blip r:embed="rId3">
+            <a:extLst>
+              <a:ext uri="{28A0092B-C50C-407E-A947-70E740481C1C}">
+                <a14:useLocalDpi xmlns:a14="http://schemas.microsoft.com/office/drawing/2010/main" val="0"/>
+              </a:ext>
+            </a:extLst>
+          </a:blip>
+          <a:srcRect/>
+          <a:stretch>
+            <a:fillRect/>
+          </a:stretch>
+        </p:blipFill>
+        <p:spPr bwMode="auto">
+          <a:xfrm>
+            <a:off x="4564048" y="1017767"/>
+            <a:ext cx="5419725" cy="5000625"/>
+          </a:xfrm>
+          <a:prstGeom prst="rect">
+            <a:avLst/>
+          </a:prstGeom>
+          <a:noFill/>
+          <a:extLst>
+            <a:ext uri="{909E8E84-426E-40DD-AFC4-6F175D3DCCD1}">
+              <a14:hiddenFill xmlns:a14="http://schemas.microsoft.com/office/drawing/2010/main">
+                <a:solidFill>
+                  <a:srgbClr val="FFFFFF"/>
+                </a:solidFill>
+              </a14:hiddenFill>
+            </a:ext>
+          </a:extLst>
+        </p:spPr>
+      </p:pic>
     </p:spTree>
     <p:extLst>
       <p:ext uri="{BB962C8B-B14F-4D97-AF65-F5344CB8AC3E}">
@@ -3966,6 +4020,348 @@
     <p:extLst>
       <p:ext uri="{BB962C8B-B14F-4D97-AF65-F5344CB8AC3E}">
         <p14:creationId xmlns:p14="http://schemas.microsoft.com/office/powerpoint/2010/main" val="4033785267"/>
+      </p:ext>
+    </p:extLst>
+  </p:cSld>
+  <p:clrMapOvr>
+    <a:masterClrMapping/>
+  </p:clrMapOvr>
+</p:sld>
+</file>
+
+<file path=ppt/slides/slide6.xml><?xml version="1.0" encoding="utf-8"?>
+<p:sld xmlns:a="http://schemas.openxmlformats.org/drawingml/2006/main" xmlns:r="http://schemas.openxmlformats.org/officeDocument/2006/relationships" xmlns:p="http://schemas.openxmlformats.org/presentationml/2006/main">
+  <p:cSld>
+    <p:spTree>
+      <p:nvGrpSpPr>
+        <p:cNvPr id="1" name=""/>
+        <p:cNvGrpSpPr/>
+        <p:nvPr/>
+      </p:nvGrpSpPr>
+      <p:grpSpPr>
+        <a:xfrm>
+          <a:off x="0" y="0"/>
+          <a:ext cx="0" cy="0"/>
+          <a:chOff x="0" y="0"/>
+          <a:chExt cx="0" cy="0"/>
+        </a:xfrm>
+      </p:grpSpPr>
+      <p:pic>
+        <p:nvPicPr>
+          <p:cNvPr id="1025" name="Picture 1">
+            <a:extLst>
+              <a:ext uri="{FF2B5EF4-FFF2-40B4-BE49-F238E27FC236}">
+                <a16:creationId xmlns:a16="http://schemas.microsoft.com/office/drawing/2014/main" id="{89CB43F5-12CA-42E7-9098-F43CB7D6DF3A}"/>
+              </a:ext>
+            </a:extLst>
+          </p:cNvPr>
+          <p:cNvPicPr>
+            <a:picLocks noChangeAspect="1" noChangeArrowheads="1"/>
+          </p:cNvPicPr>
+          <p:nvPr/>
+        </p:nvPicPr>
+        <p:blipFill>
+          <a:blip r:embed="rId2">
+            <a:extLst>
+              <a:ext uri="{28A0092B-C50C-407E-A947-70E740481C1C}">
+                <a14:useLocalDpi xmlns:a14="http://schemas.microsoft.com/office/drawing/2010/main" val="0"/>
+              </a:ext>
+            </a:extLst>
+          </a:blip>
+          <a:srcRect/>
+          <a:stretch>
+            <a:fillRect/>
+          </a:stretch>
+        </p:blipFill>
+        <p:spPr bwMode="auto">
+          <a:xfrm>
+            <a:off x="389614" y="1129085"/>
+            <a:ext cx="5010150" cy="3981450"/>
+          </a:xfrm>
+          <a:prstGeom prst="rect">
+            <a:avLst/>
+          </a:prstGeom>
+          <a:noFill/>
+          <a:extLst>
+            <a:ext uri="{909E8E84-426E-40DD-AFC4-6F175D3DCCD1}">
+              <a14:hiddenFill xmlns:a14="http://schemas.microsoft.com/office/drawing/2010/main">
+                <a:solidFill>
+                  <a:srgbClr val="FFFFFF"/>
+                </a:solidFill>
+              </a14:hiddenFill>
+            </a:ext>
+          </a:extLst>
+        </p:spPr>
+      </p:pic>
+      <p:pic>
+        <p:nvPicPr>
+          <p:cNvPr id="1026" name="Picture 2">
+            <a:extLst>
+              <a:ext uri="{FF2B5EF4-FFF2-40B4-BE49-F238E27FC236}">
+                <a16:creationId xmlns:a16="http://schemas.microsoft.com/office/drawing/2014/main" id="{A201211A-3AE1-B285-179D-EA58B840A414}"/>
+              </a:ext>
+            </a:extLst>
+          </p:cNvPr>
+          <p:cNvPicPr>
+            <a:picLocks noChangeAspect="1" noChangeArrowheads="1"/>
+          </p:cNvPicPr>
+          <p:nvPr/>
+        </p:nvPicPr>
+        <p:blipFill>
+          <a:blip r:embed="rId3">
+            <a:extLst>
+              <a:ext uri="{28A0092B-C50C-407E-A947-70E740481C1C}">
+                <a14:useLocalDpi xmlns:a14="http://schemas.microsoft.com/office/drawing/2010/main" val="0"/>
+              </a:ext>
+            </a:extLst>
+          </a:blip>
+          <a:srcRect/>
+          <a:stretch>
+            <a:fillRect/>
+          </a:stretch>
+        </p:blipFill>
+        <p:spPr bwMode="auto">
+          <a:xfrm>
+            <a:off x="5399764" y="1129085"/>
+            <a:ext cx="5010150" cy="3981450"/>
+          </a:xfrm>
+          <a:prstGeom prst="rect">
+            <a:avLst/>
+          </a:prstGeom>
+          <a:noFill/>
+          <a:extLst>
+            <a:ext uri="{909E8E84-426E-40DD-AFC4-6F175D3DCCD1}">
+              <a14:hiddenFill xmlns:a14="http://schemas.microsoft.com/office/drawing/2010/main">
+                <a:solidFill>
+                  <a:srgbClr val="FFFFFF"/>
+                </a:solidFill>
+              </a14:hiddenFill>
+            </a:ext>
+          </a:extLst>
+        </p:spPr>
+      </p:pic>
+      <p:pic>
+        <p:nvPicPr>
+          <p:cNvPr id="1027" name="Picture 3">
+            <a:extLst>
+              <a:ext uri="{FF2B5EF4-FFF2-40B4-BE49-F238E27FC236}">
+                <a16:creationId xmlns:a16="http://schemas.microsoft.com/office/drawing/2014/main" id="{56102C46-DB2F-B868-4879-7B161DE34DAA}"/>
+              </a:ext>
+            </a:extLst>
+          </p:cNvPr>
+          <p:cNvPicPr>
+            <a:picLocks noChangeAspect="1" noChangeArrowheads="1"/>
+          </p:cNvPicPr>
+          <p:nvPr/>
+        </p:nvPicPr>
+        <p:blipFill>
+          <a:blip r:embed="rId4">
+            <a:extLst>
+              <a:ext uri="{28A0092B-C50C-407E-A947-70E740481C1C}">
+                <a14:useLocalDpi xmlns:a14="http://schemas.microsoft.com/office/drawing/2010/main" val="0"/>
+              </a:ext>
+            </a:extLst>
+          </a:blip>
+          <a:srcRect/>
+          <a:stretch>
+            <a:fillRect/>
+          </a:stretch>
+        </p:blipFill>
+        <p:spPr bwMode="auto">
+          <a:xfrm>
+            <a:off x="10374299" y="1129085"/>
+            <a:ext cx="1504950" cy="4171950"/>
+          </a:xfrm>
+          <a:prstGeom prst="rect">
+            <a:avLst/>
+          </a:prstGeom>
+          <a:noFill/>
+          <a:extLst>
+            <a:ext uri="{909E8E84-426E-40DD-AFC4-6F175D3DCCD1}">
+              <a14:hiddenFill xmlns:a14="http://schemas.microsoft.com/office/drawing/2010/main">
+                <a:solidFill>
+                  <a:srgbClr val="FFFFFF"/>
+                </a:solidFill>
+              </a14:hiddenFill>
+            </a:ext>
+          </a:extLst>
+        </p:spPr>
+      </p:pic>
+      <p:pic>
+        <p:nvPicPr>
+          <p:cNvPr id="1028" name="Picture 4">
+            <a:extLst>
+              <a:ext uri="{FF2B5EF4-FFF2-40B4-BE49-F238E27FC236}">
+                <a16:creationId xmlns:a16="http://schemas.microsoft.com/office/drawing/2014/main" id="{FC5668E3-CC71-70EF-E5AB-DA1F46976E32}"/>
+              </a:ext>
+            </a:extLst>
+          </p:cNvPr>
+          <p:cNvPicPr>
+            <a:picLocks noChangeAspect="1" noChangeArrowheads="1"/>
+          </p:cNvPicPr>
+          <p:nvPr/>
+        </p:nvPicPr>
+        <p:blipFill>
+          <a:blip r:embed="rId5">
+            <a:extLst>
+              <a:ext uri="{28A0092B-C50C-407E-A947-70E740481C1C}">
+                <a14:useLocalDpi xmlns:a14="http://schemas.microsoft.com/office/drawing/2010/main" val="0"/>
+              </a:ext>
+            </a:extLst>
+          </a:blip>
+          <a:srcRect/>
+          <a:stretch>
+            <a:fillRect/>
+          </a:stretch>
+        </p:blipFill>
+        <p:spPr bwMode="auto">
+          <a:xfrm>
+            <a:off x="2973788" y="1280160"/>
+            <a:ext cx="5276850" cy="4171950"/>
+          </a:xfrm>
+          <a:prstGeom prst="rect">
+            <a:avLst/>
+          </a:prstGeom>
+          <a:noFill/>
+          <a:extLst>
+            <a:ext uri="{909E8E84-426E-40DD-AFC4-6F175D3DCCD1}">
+              <a14:hiddenFill xmlns:a14="http://schemas.microsoft.com/office/drawing/2010/main">
+                <a:solidFill>
+                  <a:srgbClr val="FFFFFF"/>
+                </a:solidFill>
+              </a14:hiddenFill>
+            </a:ext>
+          </a:extLst>
+        </p:spPr>
+      </p:pic>
+    </p:spTree>
+    <p:extLst>
+      <p:ext uri="{BB962C8B-B14F-4D97-AF65-F5344CB8AC3E}">
+        <p14:creationId xmlns:p14="http://schemas.microsoft.com/office/powerpoint/2010/main" val="1011210827"/>
+      </p:ext>
+    </p:extLst>
+  </p:cSld>
+  <p:clrMapOvr>
+    <a:masterClrMapping/>
+  </p:clrMapOvr>
+</p:sld>
+</file>
+
+<file path=ppt/slides/slide7.xml><?xml version="1.0" encoding="utf-8"?>
+<p:sld xmlns:a="http://schemas.openxmlformats.org/drawingml/2006/main" xmlns:r="http://schemas.openxmlformats.org/officeDocument/2006/relationships" xmlns:p="http://schemas.openxmlformats.org/presentationml/2006/main">
+  <p:cSld>
+    <p:spTree>
+      <p:nvGrpSpPr>
+        <p:cNvPr id="1" name=""/>
+        <p:cNvGrpSpPr/>
+        <p:nvPr/>
+      </p:nvGrpSpPr>
+      <p:grpSpPr>
+        <a:xfrm>
+          <a:off x="0" y="0"/>
+          <a:ext cx="0" cy="0"/>
+          <a:chOff x="0" y="0"/>
+          <a:chExt cx="0" cy="0"/>
+        </a:xfrm>
+      </p:grpSpPr>
+      <p:pic>
+        <p:nvPicPr>
+          <p:cNvPr id="2" name="Picture 1">
+            <a:extLst>
+              <a:ext uri="{FF2B5EF4-FFF2-40B4-BE49-F238E27FC236}">
+                <a16:creationId xmlns:a16="http://schemas.microsoft.com/office/drawing/2014/main" id="{834BF755-B921-2A7A-73E9-F78228E8244B}"/>
+              </a:ext>
+            </a:extLst>
+          </p:cNvPr>
+          <p:cNvPicPr>
+            <a:picLocks noChangeAspect="1" noChangeArrowheads="1"/>
+          </p:cNvPicPr>
+          <p:nvPr/>
+        </p:nvPicPr>
+        <p:blipFill>
+          <a:blip r:embed="rId2">
+            <a:extLst>
+              <a:ext uri="{28A0092B-C50C-407E-A947-70E740481C1C}">
+                <a14:useLocalDpi xmlns:a14="http://schemas.microsoft.com/office/drawing/2010/main" val="0"/>
+              </a:ext>
+            </a:extLst>
+          </a:blip>
+          <a:srcRect/>
+          <a:stretch>
+            <a:fillRect/>
+          </a:stretch>
+        </p:blipFill>
+        <p:spPr bwMode="auto">
+          <a:xfrm>
+            <a:off x="6265628" y="738186"/>
+            <a:ext cx="5295900" cy="5381625"/>
+          </a:xfrm>
+          <a:prstGeom prst="rect">
+            <a:avLst/>
+          </a:prstGeom>
+          <a:noFill/>
+          <a:extLst>
+            <a:ext uri="{909E8E84-426E-40DD-AFC4-6F175D3DCCD1}">
+              <a14:hiddenFill xmlns:a14="http://schemas.microsoft.com/office/drawing/2010/main">
+                <a:solidFill>
+                  <a:srgbClr val="FFFFFF"/>
+                </a:solidFill>
+              </a14:hiddenFill>
+            </a:ext>
+          </a:extLst>
+        </p:spPr>
+      </p:pic>
+      <p:pic>
+        <p:nvPicPr>
+          <p:cNvPr id="2050" name="Picture 2">
+            <a:extLst>
+              <a:ext uri="{FF2B5EF4-FFF2-40B4-BE49-F238E27FC236}">
+                <a16:creationId xmlns:a16="http://schemas.microsoft.com/office/drawing/2014/main" id="{783F8E53-197B-DF4E-7C0E-FE66F5609C8D}"/>
+              </a:ext>
+            </a:extLst>
+          </p:cNvPr>
+          <p:cNvPicPr>
+            <a:picLocks noChangeAspect="1" noChangeArrowheads="1"/>
+          </p:cNvPicPr>
+          <p:nvPr/>
+        </p:nvPicPr>
+        <p:blipFill>
+          <a:blip r:embed="rId3">
+            <a:extLst>
+              <a:ext uri="{28A0092B-C50C-407E-A947-70E740481C1C}">
+                <a14:useLocalDpi xmlns:a14="http://schemas.microsoft.com/office/drawing/2010/main" val="0"/>
+              </a:ext>
+            </a:extLst>
+          </a:blip>
+          <a:srcRect/>
+          <a:stretch>
+            <a:fillRect/>
+          </a:stretch>
+        </p:blipFill>
+        <p:spPr bwMode="auto">
+          <a:xfrm>
+            <a:off x="630472" y="1168842"/>
+            <a:ext cx="5419725" cy="5191125"/>
+          </a:xfrm>
+          <a:prstGeom prst="rect">
+            <a:avLst/>
+          </a:prstGeom>
+          <a:noFill/>
+          <a:extLst>
+            <a:ext uri="{909E8E84-426E-40DD-AFC4-6F175D3DCCD1}">
+              <a14:hiddenFill xmlns:a14="http://schemas.microsoft.com/office/drawing/2010/main">
+                <a:solidFill>
+                  <a:srgbClr val="FFFFFF"/>
+                </a:solidFill>
+              </a14:hiddenFill>
+            </a:ext>
+          </a:extLst>
+        </p:spPr>
+      </p:pic>
+    </p:spTree>
+    <p:extLst>
+      <p:ext uri="{BB962C8B-B14F-4D97-AF65-F5344CB8AC3E}">
+        <p14:creationId xmlns:p14="http://schemas.microsoft.com/office/powerpoint/2010/main" val="2592238983"/>
       </p:ext>
     </p:extLst>
   </p:cSld>

</xml_diff>